<commit_message>
Ground the proposal in full-source review and validate navigator tasks
</commit_message>
<xml_diff>
--- a/submissions/pitch/pitch-editable.pptx
+++ b/submissions/pitch/pitch-editable.pptx
@@ -2,18 +2,18 @@
 <file path=ppt/presentation.xml><?xml version="1.0" encoding="utf-8"?>
 <p:presentation xmlns:p="http://schemas.openxmlformats.org/presentationml/2006/main">
   <p:sldMasterIdLst>
-    <p:sldMasterId xmlns:r="http://schemas.openxmlformats.org/officeDocument/2006/relationships" id="2147483648" r:id="R62dc106b939e4e45"/>
+    <p:sldMasterId xmlns:r="http://schemas.openxmlformats.org/officeDocument/2006/relationships" id="2147483648" r:id="Rafa5318c5c72451c"/>
   </p:sldMasterIdLst>
   <p:notesMasterIdLst>
-    <p:notesMasterId xmlns:r="http://schemas.openxmlformats.org/officeDocument/2006/relationships" r:id="R55a8751c53684e7c"/>
+    <p:notesMasterId xmlns:r="http://schemas.openxmlformats.org/officeDocument/2006/relationships" r:id="Rb02eef124d8e4376"/>
   </p:notesMasterIdLst>
   <p:sldIdLst>
-    <p:sldId xmlns:r="http://schemas.openxmlformats.org/officeDocument/2006/relationships" id="256" r:id="R2df41d7db60341e9"/>
-    <p:sldId xmlns:r="http://schemas.openxmlformats.org/officeDocument/2006/relationships" id="257" r:id="Rdf2273c301d64b93"/>
-    <p:sldId xmlns:r="http://schemas.openxmlformats.org/officeDocument/2006/relationships" id="258" r:id="R3d68f46409374b2a"/>
-    <p:sldId xmlns:r="http://schemas.openxmlformats.org/officeDocument/2006/relationships" id="259" r:id="R4cd3f84a86b34588"/>
-    <p:sldId xmlns:r="http://schemas.openxmlformats.org/officeDocument/2006/relationships" id="260" r:id="R581c6e869f1b4027"/>
-    <p:sldId xmlns:r="http://schemas.openxmlformats.org/officeDocument/2006/relationships" id="261" r:id="R0cf3a8c98b2e4edd"/>
+    <p:sldId xmlns:r="http://schemas.openxmlformats.org/officeDocument/2006/relationships" id="256" r:id="Rd98137ac917b4a69"/>
+    <p:sldId xmlns:r="http://schemas.openxmlformats.org/officeDocument/2006/relationships" id="257" r:id="R481dc5c167ca4381"/>
+    <p:sldId xmlns:r="http://schemas.openxmlformats.org/officeDocument/2006/relationships" id="258" r:id="R28eacfc30c5a460e"/>
+    <p:sldId xmlns:r="http://schemas.openxmlformats.org/officeDocument/2006/relationships" id="259" r:id="Reaa05814bf9a4976"/>
+    <p:sldId xmlns:r="http://schemas.openxmlformats.org/officeDocument/2006/relationships" id="260" r:id="Rcee72dd333e64d65"/>
+    <p:sldId xmlns:r="http://schemas.openxmlformats.org/officeDocument/2006/relationships" id="261" r:id="R3986d87e1ab94195"/>
   </p:sldIdLst>
   <p:sldSz cx="12192000" cy="6858000"/>
   <p:notesSz cx="6858000" cy="9144000"/>
@@ -617,7 +617,7 @@
           <a:lstStyle xmlns:a="http://schemas.openxmlformats.org/drawingml/2006/main"/>
           <a:p xmlns:a="http://schemas.openxmlformats.org/drawingml/2006/main">
             <a:r>
-              <a:t>Arimoclomol has a human approval in a different disease. Its reported effects depend on the cell and the stress. That makes exposure a gate, not a footnote. First, qualify the model and measurement. Second, test whether the proposed response occurs at relevant exposure. Third, require better chromosome segregation, while tracking division, survival and cell fate. More protein alone does not pass. Neither does an apparent improvement caused by stopping division or selectively losing abnormal cells. Failed controls are indeterminate; a valid drug negative stops that tested approach.</a:t>
+              <a:t>Arimoclomol has a human approval in a different disease. Its reported effects depend on the cell and the stress. That makes exposure a gate, not a footnote. First, qualify the model and measurement. Second, test whether the proposed response occurs at relevant exposure. Third, require better chromosome segregation, while tracking division, survival and cell fate. More protein alone does not pass. Neither does an apparent improvement caused by stopping division or selectively losing abnormal cells. Failed controls are indeterminate; imprecise results are inconclusive. Rejection requires ruling out the predefined worthwhile benefit for that tested approach.</a:t>
             </a:r>
           </a:p>
           <a:p xmlns:a="http://schemas.openxmlformats.org/drawingml/2006/main">
@@ -934,7 +934,7 @@
           <p:cNvPr id="3" name="Title">
             <a:extLst xmlns:a="http://schemas.openxmlformats.org/drawingml/2006/main">
               <a:ext uri="{FF2B5EF4-FFF2-40B4-BE49-F238E27FC236}">
-                <a16:creationId xmlns:a16="http://schemas.microsoft.com/office/drawing/2014/main" id="{9E26672A-0BD8-4B14-939D-E6E87825A6F7}"/>
+                <a16:creationId xmlns:a16="http://schemas.microsoft.com/office/drawing/2014/main" id="{33213186-2011-41DB-A487-0EA34FA2DC63}"/>
               </a:ext>
             </a:extLst>
           </p:cNvPr>
@@ -1163,7 +1163,7 @@
           <p:cNvPr id="2" name="Subtitle">
             <a:extLst xmlns:a="http://schemas.openxmlformats.org/drawingml/2006/main">
               <a:ext uri="{FF2B5EF4-FFF2-40B4-BE49-F238E27FC236}">
-                <a16:creationId xmlns:a16="http://schemas.microsoft.com/office/drawing/2014/main" id="{6D6C9126-9651-456E-BE42-32DD96EB3004}"/>
+                <a16:creationId xmlns:a16="http://schemas.microsoft.com/office/drawing/2014/main" id="{A40DC243-CE2F-4913-AA7C-DF1253F7078F}"/>
               </a:ext>
             </a:extLst>
           </p:cNvPr>
@@ -1409,7 +1409,7 @@
           <p:cNvPr id="2" name="Section title">
             <a:extLst xmlns:a="http://schemas.openxmlformats.org/drawingml/2006/main">
               <a:ext uri="{FF2B5EF4-FFF2-40B4-BE49-F238E27FC236}">
-                <a16:creationId xmlns:a16="http://schemas.microsoft.com/office/drawing/2014/main" id="{0EFFF192-AF36-4A9E-84D2-29D17A2D29A7}"/>
+                <a16:creationId xmlns:a16="http://schemas.microsoft.com/office/drawing/2014/main" id="{A8BBE07B-D9FA-4E2E-8DA3-723D8382A03C}"/>
               </a:ext>
             </a:extLst>
           </p:cNvPr>
@@ -1655,7 +1655,7 @@
           <p:cNvPr id="3" name="Title">
             <a:extLst xmlns:a="http://schemas.openxmlformats.org/drawingml/2006/main">
               <a:ext uri="{FF2B5EF4-FFF2-40B4-BE49-F238E27FC236}">
-                <a16:creationId xmlns:a16="http://schemas.microsoft.com/office/drawing/2014/main" id="{B4D52AAE-B93B-4D1C-ACE4-89B007F50A37}"/>
+                <a16:creationId xmlns:a16="http://schemas.microsoft.com/office/drawing/2014/main" id="{139E13A6-694C-4304-81F8-6A2BF92437F3}"/>
               </a:ext>
             </a:extLst>
           </p:cNvPr>
@@ -1884,7 +1884,7 @@
           <p:cNvPr id="2" name="Body">
             <a:extLst xmlns:a="http://schemas.openxmlformats.org/drawingml/2006/main">
               <a:ext uri="{FF2B5EF4-FFF2-40B4-BE49-F238E27FC236}">
-                <a16:creationId xmlns:a16="http://schemas.microsoft.com/office/drawing/2014/main" id="{F99218CB-44B8-4F42-B833-F6CD5396F78D}"/>
+                <a16:creationId xmlns:a16="http://schemas.microsoft.com/office/drawing/2014/main" id="{9FFADA0D-8CF7-450B-AF94-0E5F6241B06C}"/>
               </a:ext>
             </a:extLst>
           </p:cNvPr>
@@ -2130,7 +2130,7 @@
           <p:cNvPr id="4" name="Title">
             <a:extLst xmlns:a="http://schemas.openxmlformats.org/drawingml/2006/main">
               <a:ext uri="{FF2B5EF4-FFF2-40B4-BE49-F238E27FC236}">
-                <a16:creationId xmlns:a16="http://schemas.microsoft.com/office/drawing/2014/main" id="{B25283BC-8C54-4B0E-9853-B93D38C52FA5}"/>
+                <a16:creationId xmlns:a16="http://schemas.microsoft.com/office/drawing/2014/main" id="{7B7B5A64-82C4-4C7A-9C7D-70314B487E76}"/>
               </a:ext>
             </a:extLst>
           </p:cNvPr>
@@ -2359,7 +2359,7 @@
           <p:cNvPr id="2" name="Left column">
             <a:extLst xmlns:a="http://schemas.openxmlformats.org/drawingml/2006/main">
               <a:ext uri="{FF2B5EF4-FFF2-40B4-BE49-F238E27FC236}">
-                <a16:creationId xmlns:a16="http://schemas.microsoft.com/office/drawing/2014/main" id="{EBB644E3-C4CD-4031-9163-EE0808E0E314}"/>
+                <a16:creationId xmlns:a16="http://schemas.microsoft.com/office/drawing/2014/main" id="{3F8E1C51-AADF-4E80-86A4-323C8A57C161}"/>
               </a:ext>
             </a:extLst>
           </p:cNvPr>
@@ -2588,7 +2588,7 @@
           <p:cNvPr id="3" name="Right column">
             <a:extLst xmlns:a="http://schemas.openxmlformats.org/drawingml/2006/main">
               <a:ext uri="{FF2B5EF4-FFF2-40B4-BE49-F238E27FC236}">
-                <a16:creationId xmlns:a16="http://schemas.microsoft.com/office/drawing/2014/main" id="{A362B639-2792-4893-9BB5-8D9A038E4900}"/>
+                <a16:creationId xmlns:a16="http://schemas.microsoft.com/office/drawing/2014/main" id="{AB0B37ED-4236-4024-8F53-6D624FA48D6E}"/>
               </a:ext>
             </a:extLst>
           </p:cNvPr>
@@ -2834,7 +2834,7 @@
           <p:cNvPr id="3" name="Title">
             <a:extLst xmlns:a="http://schemas.openxmlformats.org/drawingml/2006/main">
               <a:ext uri="{FF2B5EF4-FFF2-40B4-BE49-F238E27FC236}">
-                <a16:creationId xmlns:a16="http://schemas.microsoft.com/office/drawing/2014/main" id="{62D6CEAD-56BD-487F-B823-1056F2CF354F}"/>
+                <a16:creationId xmlns:a16="http://schemas.microsoft.com/office/drawing/2014/main" id="{20AE6ED9-B877-4D9D-AAD5-8730471BD052}"/>
               </a:ext>
             </a:extLst>
           </p:cNvPr>
@@ -3063,7 +3063,7 @@
           <p:cNvPr id="2" name="Left column">
             <a:extLst xmlns:a="http://schemas.openxmlformats.org/drawingml/2006/main">
               <a:ext uri="{FF2B5EF4-FFF2-40B4-BE49-F238E27FC236}">
-                <a16:creationId xmlns:a16="http://schemas.microsoft.com/office/drawing/2014/main" id="{FF623D88-E874-48D2-A29A-CCB97CDCD2CC}"/>
+                <a16:creationId xmlns:a16="http://schemas.microsoft.com/office/drawing/2014/main" id="{EAE38C5F-7D84-48C4-8D8E-05274637D310}"/>
               </a:ext>
             </a:extLst>
           </p:cNvPr>
@@ -3330,12 +3330,12 @@
   </p:cSld>
   <p:clrMap bg1="lt1" tx1="dk1" bg2="lt2" tx2="dk2" accent1="accent1" accent2="accent2" accent3="accent3" accent4="accent4" accent5="accent5" accent6="accent6" hlink="hlink" folHlink="folHlink"/>
   <p:sldLayoutIdLst>
-    <p:sldLayoutId xmlns:r="http://schemas.openxmlformats.org/officeDocument/2006/relationships" id="2147483649" r:id="Rafd453d9c3a24c83"/>
-    <p:sldLayoutId xmlns:r="http://schemas.openxmlformats.org/officeDocument/2006/relationships" id="2147483650" r:id="Rf92a271fdaed4c18"/>
-    <p:sldLayoutId xmlns:r="http://schemas.openxmlformats.org/officeDocument/2006/relationships" id="2147483651" r:id="R2b38af82438d43e1"/>
-    <p:sldLayoutId xmlns:r="http://schemas.openxmlformats.org/officeDocument/2006/relationships" id="2147483652" r:id="Rec74878394824d1f"/>
-    <p:sldLayoutId xmlns:r="http://schemas.openxmlformats.org/officeDocument/2006/relationships" id="2147483653" r:id="R10ccd36aa1a441dc"/>
-    <p:sldLayoutId xmlns:r="http://schemas.openxmlformats.org/officeDocument/2006/relationships" id="2147483654" r:id="Rc45625d4b480496f"/>
+    <p:sldLayoutId xmlns:r="http://schemas.openxmlformats.org/officeDocument/2006/relationships" id="2147483649" r:id="Rfc0cb8d32bbc4365"/>
+    <p:sldLayoutId xmlns:r="http://schemas.openxmlformats.org/officeDocument/2006/relationships" id="2147483650" r:id="Ra677f5e220424af5"/>
+    <p:sldLayoutId xmlns:r="http://schemas.openxmlformats.org/officeDocument/2006/relationships" id="2147483651" r:id="Rf742069349334e45"/>
+    <p:sldLayoutId xmlns:r="http://schemas.openxmlformats.org/officeDocument/2006/relationships" id="2147483652" r:id="R51161aecb67d46b2"/>
+    <p:sldLayoutId xmlns:r="http://schemas.openxmlformats.org/officeDocument/2006/relationships" id="2147483653" r:id="R644f210e19c34de6"/>
+    <p:sldLayoutId xmlns:r="http://schemas.openxmlformats.org/officeDocument/2006/relationships" id="2147483654" r:id="R7d468a65e2284368"/>
   </p:sldLayoutIdLst>
   <p:txStyles>
     <p:titleStyle>
@@ -3886,7 +3886,7 @@
           <p:cNvPr id="8" name="">
             <a:extLst xmlns:a="http://schemas.openxmlformats.org/drawingml/2006/main">
               <a:ext uri="{FF2B5EF4-FFF2-40B4-BE49-F238E27FC236}">
-                <a16:creationId xmlns:a16="http://schemas.microsoft.com/office/drawing/2014/main" id="{0F0C3646-FD7E-4423-B13F-94ED5317265A}"/>
+                <a16:creationId xmlns:a16="http://schemas.microsoft.com/office/drawing/2014/main" id="{B17A3B96-022B-40A3-BA0B-3C38097F00E0}"/>
               </a:ext>
             </a:extLst>
           </p:cNvPr>
@@ -4042,7 +4042,7 @@
           <p:cNvPr id="2" name="">
             <a:extLst xmlns:a="http://schemas.openxmlformats.org/drawingml/2006/main">
               <a:ext uri="{FF2B5EF4-FFF2-40B4-BE49-F238E27FC236}">
-                <a16:creationId xmlns:a16="http://schemas.microsoft.com/office/drawing/2014/main" id="{3EA2881B-4E20-477E-97E2-250D40219977}"/>
+                <a16:creationId xmlns:a16="http://schemas.microsoft.com/office/drawing/2014/main" id="{ECB9AD98-87A9-42FB-8C98-9936EA791E7A}"/>
               </a:ext>
             </a:extLst>
           </p:cNvPr>
@@ -4198,7 +4198,7 @@
           <p:cNvPr id="3" name="">
             <a:extLst xmlns:a="http://schemas.openxmlformats.org/drawingml/2006/main">
               <a:ext uri="{FF2B5EF4-FFF2-40B4-BE49-F238E27FC236}">
-                <a16:creationId xmlns:a16="http://schemas.microsoft.com/office/drawing/2014/main" id="{027211C4-64A3-4D1B-A155-A33601701FED}"/>
+                <a16:creationId xmlns:a16="http://schemas.microsoft.com/office/drawing/2014/main" id="{4874946E-3960-4519-B30E-EDAD5BCBA488}"/>
               </a:ext>
             </a:extLst>
           </p:cNvPr>
@@ -4354,7 +4354,7 @@
           <p:cNvPr id="4" name="">
             <a:extLst xmlns:a="http://schemas.openxmlformats.org/drawingml/2006/main">
               <a:ext uri="{FF2B5EF4-FFF2-40B4-BE49-F238E27FC236}">
-                <a16:creationId xmlns:a16="http://schemas.microsoft.com/office/drawing/2014/main" id="{49641991-6C6B-40E0-8CC0-7E32E4B15352}"/>
+                <a16:creationId xmlns:a16="http://schemas.microsoft.com/office/drawing/2014/main" id="{1407AE52-AAAC-4854-B759-653EACD6BFEF}"/>
               </a:ext>
             </a:extLst>
           </p:cNvPr>
@@ -4510,7 +4510,7 @@
           <p:cNvPr id="5" name="">
             <a:extLst xmlns:a="http://schemas.openxmlformats.org/drawingml/2006/main">
               <a:ext uri="{FF2B5EF4-FFF2-40B4-BE49-F238E27FC236}">
-                <a16:creationId xmlns:a16="http://schemas.microsoft.com/office/drawing/2014/main" id="{AFCD3A64-78BA-4433-8814-A71412ECE6E2}"/>
+                <a16:creationId xmlns:a16="http://schemas.microsoft.com/office/drawing/2014/main" id="{085BDD4C-D27F-4300-918F-8B8E8F2E1993}"/>
               </a:ext>
             </a:extLst>
           </p:cNvPr>
@@ -4689,7 +4689,7 @@
           <p:cNvPr id="6" name="">
             <a:extLst xmlns:a="http://schemas.openxmlformats.org/drawingml/2006/main">
               <a:ext uri="{FF2B5EF4-FFF2-40B4-BE49-F238E27FC236}">
-                <a16:creationId xmlns:a16="http://schemas.microsoft.com/office/drawing/2014/main" id="{929B548C-9630-4334-9489-BE53D9A333DB}"/>
+                <a16:creationId xmlns:a16="http://schemas.microsoft.com/office/drawing/2014/main" id="{339BB9B3-1F8E-4A65-8F74-8BCFD0EC44FC}"/>
               </a:ext>
             </a:extLst>
           </p:cNvPr>
@@ -4868,7 +4868,7 @@
           <p:cNvPr id="7" name="">
             <a:extLst xmlns:a="http://schemas.openxmlformats.org/drawingml/2006/main">
               <a:ext uri="{FF2B5EF4-FFF2-40B4-BE49-F238E27FC236}">
-                <a16:creationId xmlns:a16="http://schemas.microsoft.com/office/drawing/2014/main" id="{4B491A65-30BC-4883-8863-C899720C249C}"/>
+                <a16:creationId xmlns:a16="http://schemas.microsoft.com/office/drawing/2014/main" id="{71391C01-CB57-442A-A030-D71E22945752}"/>
               </a:ext>
             </a:extLst>
           </p:cNvPr>
@@ -5045,7 +5045,7 @@
     </p:spTree>
     <p:extLst>
       <p:ext uri="{BB962C8B-B14F-4D97-AF65-F5344CB8AC3E}">
-        <p14:creationId xmlns:p14="http://schemas.microsoft.com/office/powerpoint/2010/main" val="1824133070"/>
+        <p14:creationId xmlns:p14="http://schemas.microsoft.com/office/powerpoint/2010/main" val="772576204"/>
       </p:ext>
     </p:extLst>
   </p:cSld>
@@ -5076,7 +5076,7 @@
           <p:cNvPr id="10" name="">
             <a:extLst xmlns:a="http://schemas.openxmlformats.org/drawingml/2006/main">
               <a:ext uri="{FF2B5EF4-FFF2-40B4-BE49-F238E27FC236}">
-                <a16:creationId xmlns:a16="http://schemas.microsoft.com/office/drawing/2014/main" id="{8092298C-82E9-48E2-A4D0-C8732BF995C6}"/>
+                <a16:creationId xmlns:a16="http://schemas.microsoft.com/office/drawing/2014/main" id="{3EF24068-485B-453A-BA0B-C91F5B5B342E}"/>
               </a:ext>
             </a:extLst>
           </p:cNvPr>
@@ -5232,7 +5232,7 @@
           <p:cNvPr id="2" name="">
             <a:extLst xmlns:a="http://schemas.openxmlformats.org/drawingml/2006/main">
               <a:ext uri="{FF2B5EF4-FFF2-40B4-BE49-F238E27FC236}">
-                <a16:creationId xmlns:a16="http://schemas.microsoft.com/office/drawing/2014/main" id="{351AD91F-85C9-4B2B-8941-0253FBA1834F}"/>
+                <a16:creationId xmlns:a16="http://schemas.microsoft.com/office/drawing/2014/main" id="{5E469EE0-D3B8-4537-8948-1FE59B00D213}"/>
               </a:ext>
             </a:extLst>
           </p:cNvPr>
@@ -5388,7 +5388,7 @@
           <p:cNvPr id="3" name="">
             <a:extLst xmlns:a="http://schemas.openxmlformats.org/drawingml/2006/main">
               <a:ext uri="{FF2B5EF4-FFF2-40B4-BE49-F238E27FC236}">
-                <a16:creationId xmlns:a16="http://schemas.microsoft.com/office/drawing/2014/main" id="{A1555F63-7145-4083-965D-E7F8DAEA019C}"/>
+                <a16:creationId xmlns:a16="http://schemas.microsoft.com/office/drawing/2014/main" id="{6B396105-0B19-44D9-B46D-593526F3547B}"/>
               </a:ext>
             </a:extLst>
           </p:cNvPr>
@@ -5544,7 +5544,7 @@
           <p:cNvPr id="4" name="">
             <a:extLst xmlns:a="http://schemas.openxmlformats.org/drawingml/2006/main">
               <a:ext uri="{FF2B5EF4-FFF2-40B4-BE49-F238E27FC236}">
-                <a16:creationId xmlns:a16="http://schemas.microsoft.com/office/drawing/2014/main" id="{AA239D85-1A59-41F0-93B0-12E1B8954A20}"/>
+                <a16:creationId xmlns:a16="http://schemas.microsoft.com/office/drawing/2014/main" id="{A1333F4C-A57F-41CB-9A55-725EB7BCB806}"/>
               </a:ext>
             </a:extLst>
           </p:cNvPr>
@@ -5700,7 +5700,7 @@
           <p:cNvPr id="5" name="">
             <a:extLst xmlns:a="http://schemas.openxmlformats.org/drawingml/2006/main">
               <a:ext uri="{FF2B5EF4-FFF2-40B4-BE49-F238E27FC236}">
-                <a16:creationId xmlns:a16="http://schemas.microsoft.com/office/drawing/2014/main" id="{40A40DB2-CCE0-4E11-B899-55AA0E57DFB0}"/>
+                <a16:creationId xmlns:a16="http://schemas.microsoft.com/office/drawing/2014/main" id="{B990EE14-CCA0-46B4-951C-D8EACDC6FFB4}"/>
               </a:ext>
             </a:extLst>
           </p:cNvPr>
@@ -5856,7 +5856,7 @@
           <p:cNvPr id="6" name="">
             <a:extLst xmlns:a="http://schemas.openxmlformats.org/drawingml/2006/main">
               <a:ext uri="{FF2B5EF4-FFF2-40B4-BE49-F238E27FC236}">
-                <a16:creationId xmlns:a16="http://schemas.microsoft.com/office/drawing/2014/main" id="{9DCB92E0-2E4B-401E-8B3E-4A889D607AA3}"/>
+                <a16:creationId xmlns:a16="http://schemas.microsoft.com/office/drawing/2014/main" id="{F84E5752-C2C0-4AF1-82BF-770FE314AF47}"/>
               </a:ext>
             </a:extLst>
           </p:cNvPr>
@@ -6035,7 +6035,7 @@
           <p:cNvPr id="7" name="">
             <a:extLst xmlns:a="http://schemas.openxmlformats.org/drawingml/2006/main">
               <a:ext uri="{FF2B5EF4-FFF2-40B4-BE49-F238E27FC236}">
-                <a16:creationId xmlns:a16="http://schemas.microsoft.com/office/drawing/2014/main" id="{C0BD546A-7DE5-4367-AF5C-32C583CDFB16}"/>
+                <a16:creationId xmlns:a16="http://schemas.microsoft.com/office/drawing/2014/main" id="{58436EDB-5D76-491D-830A-A9985FB89D3B}"/>
               </a:ext>
             </a:extLst>
           </p:cNvPr>
@@ -6191,7 +6191,7 @@
           <p:cNvPr id="8" name="">
             <a:extLst xmlns:a="http://schemas.openxmlformats.org/drawingml/2006/main">
               <a:ext uri="{FF2B5EF4-FFF2-40B4-BE49-F238E27FC236}">
-                <a16:creationId xmlns:a16="http://schemas.microsoft.com/office/drawing/2014/main" id="{9190D3CC-7E71-4ED2-A512-E07204A39DB4}"/>
+                <a16:creationId xmlns:a16="http://schemas.microsoft.com/office/drawing/2014/main" id="{867C8EAE-E6E3-4FBB-A818-0AA7E21568F2}"/>
               </a:ext>
             </a:extLst>
           </p:cNvPr>
@@ -6370,7 +6370,7 @@
           <p:cNvPr id="9" name="">
             <a:extLst xmlns:a="http://schemas.openxmlformats.org/drawingml/2006/main">
               <a:ext uri="{FF2B5EF4-FFF2-40B4-BE49-F238E27FC236}">
-                <a16:creationId xmlns:a16="http://schemas.microsoft.com/office/drawing/2014/main" id="{7BE398CC-A33D-4601-A225-1F8D327BBEDC}"/>
+                <a16:creationId xmlns:a16="http://schemas.microsoft.com/office/drawing/2014/main" id="{D9CF0EAA-4FC0-447E-A776-81F9DCC74B7C}"/>
               </a:ext>
             </a:extLst>
           </p:cNvPr>
@@ -6524,7 +6524,7 @@
     </p:spTree>
     <p:extLst>
       <p:ext uri="{BB962C8B-B14F-4D97-AF65-F5344CB8AC3E}">
-        <p14:creationId xmlns:p14="http://schemas.microsoft.com/office/powerpoint/2010/main" val="1140472446"/>
+        <p14:creationId xmlns:p14="http://schemas.microsoft.com/office/powerpoint/2010/main" val="829705835"/>
       </p:ext>
     </p:extLst>
   </p:cSld>
@@ -6555,7 +6555,7 @@
           <p:cNvPr id="14" name="">
             <a:extLst xmlns:a="http://schemas.openxmlformats.org/drawingml/2006/main">
               <a:ext uri="{FF2B5EF4-FFF2-40B4-BE49-F238E27FC236}">
-                <a16:creationId xmlns:a16="http://schemas.microsoft.com/office/drawing/2014/main" id="{28C25CEE-88BE-4CFC-BDB0-3D403E6C170E}"/>
+                <a16:creationId xmlns:a16="http://schemas.microsoft.com/office/drawing/2014/main" id="{0923F183-4C32-42B2-87C4-57C74FFC96A3}"/>
               </a:ext>
             </a:extLst>
           </p:cNvPr>
@@ -6711,7 +6711,7 @@
           <p:cNvPr id="2" name="">
             <a:extLst xmlns:a="http://schemas.openxmlformats.org/drawingml/2006/main">
               <a:ext uri="{FF2B5EF4-FFF2-40B4-BE49-F238E27FC236}">
-                <a16:creationId xmlns:a16="http://schemas.microsoft.com/office/drawing/2014/main" id="{4AA0EF36-F9AB-4860-8CD8-B80F4F27E12A}"/>
+                <a16:creationId xmlns:a16="http://schemas.microsoft.com/office/drawing/2014/main" id="{110A6920-854C-4CCB-B26D-AB01D37A6FCD}"/>
               </a:ext>
             </a:extLst>
           </p:cNvPr>
@@ -6867,7 +6867,7 @@
           <p:cNvPr id="3" name="">
             <a:extLst xmlns:a="http://schemas.openxmlformats.org/drawingml/2006/main">
               <a:ext uri="{FF2B5EF4-FFF2-40B4-BE49-F238E27FC236}">
-                <a16:creationId xmlns:a16="http://schemas.microsoft.com/office/drawing/2014/main" id="{8EB98FC6-055B-43D2-9274-F4AF9C84B92D}"/>
+                <a16:creationId xmlns:a16="http://schemas.microsoft.com/office/drawing/2014/main" id="{CAB99C2B-F325-4866-8F68-0995514228EF}"/>
               </a:ext>
             </a:extLst>
           </p:cNvPr>
@@ -7023,7 +7023,7 @@
           <p:cNvPr id="4" name="">
             <a:extLst xmlns:a="http://schemas.openxmlformats.org/drawingml/2006/main">
               <a:ext uri="{FF2B5EF4-FFF2-40B4-BE49-F238E27FC236}">
-                <a16:creationId xmlns:a16="http://schemas.microsoft.com/office/drawing/2014/main" id="{EB46C945-B9F0-42F2-BE8C-A4719FFC5286}"/>
+                <a16:creationId xmlns:a16="http://schemas.microsoft.com/office/drawing/2014/main" id="{04DEBED9-26D4-4404-BC2E-550A7786073B}"/>
               </a:ext>
             </a:extLst>
           </p:cNvPr>
@@ -7179,7 +7179,7 @@
           <p:cNvPr id="5" name="">
             <a:extLst xmlns:a="http://schemas.openxmlformats.org/drawingml/2006/main">
               <a:ext uri="{FF2B5EF4-FFF2-40B4-BE49-F238E27FC236}">
-                <a16:creationId xmlns:a16="http://schemas.microsoft.com/office/drawing/2014/main" id="{7F0318EB-3FAD-4356-9189-A7404A46C801}"/>
+                <a16:creationId xmlns:a16="http://schemas.microsoft.com/office/drawing/2014/main" id="{EF18561C-2965-41F8-AB12-BBBC0F1A955A}"/>
               </a:ext>
             </a:extLst>
           </p:cNvPr>
@@ -7335,7 +7335,7 @@
           <p:cNvPr id="6" name="">
             <a:extLst xmlns:a="http://schemas.openxmlformats.org/drawingml/2006/main">
               <a:ext uri="{FF2B5EF4-FFF2-40B4-BE49-F238E27FC236}">
-                <a16:creationId xmlns:a16="http://schemas.microsoft.com/office/drawing/2014/main" id="{A6B1AD68-C85D-4393-B520-6ED1A3331A2D}"/>
+                <a16:creationId xmlns:a16="http://schemas.microsoft.com/office/drawing/2014/main" id="{F710CFEC-3A3A-467F-9076-D5B91EF2A020}"/>
               </a:ext>
             </a:extLst>
           </p:cNvPr>
@@ -7491,7 +7491,7 @@
           <p:cNvPr id="7" name="">
             <a:extLst xmlns:a="http://schemas.openxmlformats.org/drawingml/2006/main">
               <a:ext uri="{FF2B5EF4-FFF2-40B4-BE49-F238E27FC236}">
-                <a16:creationId xmlns:a16="http://schemas.microsoft.com/office/drawing/2014/main" id="{44E40D9E-B261-4134-9B78-3A2D7755C27A}"/>
+                <a16:creationId xmlns:a16="http://schemas.microsoft.com/office/drawing/2014/main" id="{36ED53D6-71B9-4A71-A8E4-55B6D40BABD2}"/>
               </a:ext>
             </a:extLst>
           </p:cNvPr>
@@ -7647,7 +7647,7 @@
           <p:cNvPr id="8" name="">
             <a:extLst xmlns:a="http://schemas.openxmlformats.org/drawingml/2006/main">
               <a:ext uri="{FF2B5EF4-FFF2-40B4-BE49-F238E27FC236}">
-                <a16:creationId xmlns:a16="http://schemas.microsoft.com/office/drawing/2014/main" id="{C4014B52-3FB4-497C-89EB-C8D2CB9D833B}"/>
+                <a16:creationId xmlns:a16="http://schemas.microsoft.com/office/drawing/2014/main" id="{ADA79870-483F-48B6-B978-013349CF87EB}"/>
               </a:ext>
             </a:extLst>
           </p:cNvPr>
@@ -7803,7 +7803,7 @@
           <p:cNvPr id="9" name="">
             <a:extLst xmlns:a="http://schemas.openxmlformats.org/drawingml/2006/main">
               <a:ext uri="{FF2B5EF4-FFF2-40B4-BE49-F238E27FC236}">
-                <a16:creationId xmlns:a16="http://schemas.microsoft.com/office/drawing/2014/main" id="{03845682-3950-4282-9D90-AC542B32BDC8}"/>
+                <a16:creationId xmlns:a16="http://schemas.microsoft.com/office/drawing/2014/main" id="{799FF9C4-1313-41F3-8E54-575854E4EF0B}"/>
               </a:ext>
             </a:extLst>
           </p:cNvPr>
@@ -7959,7 +7959,7 @@
           <p:cNvPr id="10" name="">
             <a:extLst xmlns:a="http://schemas.openxmlformats.org/drawingml/2006/main">
               <a:ext uri="{FF2B5EF4-FFF2-40B4-BE49-F238E27FC236}">
-                <a16:creationId xmlns:a16="http://schemas.microsoft.com/office/drawing/2014/main" id="{11539135-533C-4241-B4C1-D4E2225B08E0}"/>
+                <a16:creationId xmlns:a16="http://schemas.microsoft.com/office/drawing/2014/main" id="{F64A83AA-17B9-4CA6-93A3-6EF4B01E3A9A}"/>
               </a:ext>
             </a:extLst>
           </p:cNvPr>
@@ -8115,7 +8115,7 @@
           <p:cNvPr id="11" name="">
             <a:extLst xmlns:a="http://schemas.openxmlformats.org/drawingml/2006/main">
               <a:ext uri="{FF2B5EF4-FFF2-40B4-BE49-F238E27FC236}">
-                <a16:creationId xmlns:a16="http://schemas.microsoft.com/office/drawing/2014/main" id="{8D306007-3E83-4301-8A9F-06A527335EA7}"/>
+                <a16:creationId xmlns:a16="http://schemas.microsoft.com/office/drawing/2014/main" id="{ED7D8125-00D4-43C1-AF24-CC9953EF460B}"/>
               </a:ext>
             </a:extLst>
           </p:cNvPr>
@@ -8271,7 +8271,7 @@
           <p:cNvPr id="12" name="">
             <a:extLst xmlns:a="http://schemas.openxmlformats.org/drawingml/2006/main">
               <a:ext uri="{FF2B5EF4-FFF2-40B4-BE49-F238E27FC236}">
-                <a16:creationId xmlns:a16="http://schemas.microsoft.com/office/drawing/2014/main" id="{9FEC8039-ECB6-4A20-9A18-7C3D4A3265D1}"/>
+                <a16:creationId xmlns:a16="http://schemas.microsoft.com/office/drawing/2014/main" id="{8A35DA0E-DD17-41B8-9A68-D31EFAC3E493}"/>
               </a:ext>
             </a:extLst>
           </p:cNvPr>
@@ -8427,7 +8427,7 @@
           <p:cNvPr id="13" name="">
             <a:extLst xmlns:a="http://schemas.openxmlformats.org/drawingml/2006/main">
               <a:ext uri="{FF2B5EF4-FFF2-40B4-BE49-F238E27FC236}">
-                <a16:creationId xmlns:a16="http://schemas.microsoft.com/office/drawing/2014/main" id="{DD36833D-E75F-4F0C-8FFF-653152FB61DB}"/>
+                <a16:creationId xmlns:a16="http://schemas.microsoft.com/office/drawing/2014/main" id="{D441342C-23A2-4976-A871-93AD7F660A80}"/>
               </a:ext>
             </a:extLst>
           </p:cNvPr>
@@ -8573,7 +8573,7 @@
                 <a:ea typeface="Arial"/>
                 <a:cs typeface="Arial"/>
               </a:rPr>
-              <a:t>Failed controls: indeterminate. Valid drug negative: stop the tested approach.</a:t>
+              <a:t>Failed controls: indeterminate. Imprecise benefit: inconclusive.</a:t>
             </a:r>
           </a:p>
         </p:txBody>
@@ -8581,7 +8581,7 @@
     </p:spTree>
     <p:extLst>
       <p:ext uri="{BB962C8B-B14F-4D97-AF65-F5344CB8AC3E}">
-        <p14:creationId xmlns:p14="http://schemas.microsoft.com/office/powerpoint/2010/main" val="1319984067"/>
+        <p14:creationId xmlns:p14="http://schemas.microsoft.com/office/powerpoint/2010/main" val="450152459"/>
       </p:ext>
     </p:extLst>
   </p:cSld>
@@ -8612,7 +8612,7 @@
           <p:cNvPr id="8" name="">
             <a:extLst xmlns:a="http://schemas.openxmlformats.org/drawingml/2006/main">
               <a:ext uri="{FF2B5EF4-FFF2-40B4-BE49-F238E27FC236}">
-                <a16:creationId xmlns:a16="http://schemas.microsoft.com/office/drawing/2014/main" id="{1A4C2374-A9F1-443C-BCD8-51716206D385}"/>
+                <a16:creationId xmlns:a16="http://schemas.microsoft.com/office/drawing/2014/main" id="{F7921839-C9E2-485D-8BEC-C77FE55CE71B}"/>
               </a:ext>
             </a:extLst>
           </p:cNvPr>
@@ -8768,7 +8768,7 @@
           <p:cNvPr id="2" name="">
             <a:extLst xmlns:a="http://schemas.openxmlformats.org/drawingml/2006/main">
               <a:ext uri="{FF2B5EF4-FFF2-40B4-BE49-F238E27FC236}">
-                <a16:creationId xmlns:a16="http://schemas.microsoft.com/office/drawing/2014/main" id="{EBBA75DD-244D-402A-BFC0-7B746125AC1D}"/>
+                <a16:creationId xmlns:a16="http://schemas.microsoft.com/office/drawing/2014/main" id="{8D91B7CF-5870-440D-9B00-466AFEBB62C7}"/>
               </a:ext>
             </a:extLst>
           </p:cNvPr>
@@ -8924,7 +8924,7 @@
           <p:cNvPr id="3" name="">
             <a:extLst xmlns:a="http://schemas.openxmlformats.org/drawingml/2006/main">
               <a:ext uri="{FF2B5EF4-FFF2-40B4-BE49-F238E27FC236}">
-                <a16:creationId xmlns:a16="http://schemas.microsoft.com/office/drawing/2014/main" id="{B6FE5B9C-2732-40ED-8999-6CD9C5DE9ABB}"/>
+                <a16:creationId xmlns:a16="http://schemas.microsoft.com/office/drawing/2014/main" id="{FA6D18F6-62BB-4B9A-94E7-BC0E510E680A}"/>
               </a:ext>
             </a:extLst>
           </p:cNvPr>
@@ -9080,7 +9080,7 @@
           <p:cNvPr id="4" name="">
             <a:extLst xmlns:a="http://schemas.openxmlformats.org/drawingml/2006/main">
               <a:ext uri="{FF2B5EF4-FFF2-40B4-BE49-F238E27FC236}">
-                <a16:creationId xmlns:a16="http://schemas.microsoft.com/office/drawing/2014/main" id="{F181680B-8BB7-4CD7-BB44-6E36FD41DB30}"/>
+                <a16:creationId xmlns:a16="http://schemas.microsoft.com/office/drawing/2014/main" id="{9EAE199B-E311-48A1-82AC-4FDE572B9897}"/>
               </a:ext>
             </a:extLst>
           </p:cNvPr>
@@ -9090,7 +9090,7 @@
           <p:nvPr/>
         </p:nvPicPr>
         <p:blipFill>
-          <a:blip xmlns:r="http://schemas.openxmlformats.org/officeDocument/2006/relationships" xmlns:a="http://schemas.openxmlformats.org/drawingml/2006/main" r:embed="R3127376f20c947ed"/>
+          <a:blip xmlns:r="http://schemas.openxmlformats.org/officeDocument/2006/relationships" xmlns:a="http://schemas.openxmlformats.org/drawingml/2006/main" r:embed="R20eb72fb89ab42d4"/>
           <a:stretch xmlns:a="http://schemas.openxmlformats.org/drawingml/2006/main"/>
         </p:blipFill>
         <p:spPr>
@@ -9108,7 +9108,7 @@
           <p:cNvPr id="5" name="">
             <a:extLst xmlns:a="http://schemas.openxmlformats.org/drawingml/2006/main">
               <a:ext uri="{FF2B5EF4-FFF2-40B4-BE49-F238E27FC236}">
-                <a16:creationId xmlns:a16="http://schemas.microsoft.com/office/drawing/2014/main" id="{1BC9EB1C-4DFB-462B-8051-A4446A6A9869}"/>
+                <a16:creationId xmlns:a16="http://schemas.microsoft.com/office/drawing/2014/main" id="{91C27E03-CE54-4DD5-8A63-CED22F23F59C}"/>
               </a:ext>
             </a:extLst>
           </p:cNvPr>
@@ -9264,7 +9264,7 @@
           <p:cNvPr id="6" name="">
             <a:extLst xmlns:a="http://schemas.openxmlformats.org/drawingml/2006/main">
               <a:ext uri="{FF2B5EF4-FFF2-40B4-BE49-F238E27FC236}">
-                <a16:creationId xmlns:a16="http://schemas.microsoft.com/office/drawing/2014/main" id="{A0386C30-A5F4-41FB-A68D-4129467B735C}"/>
+                <a16:creationId xmlns:a16="http://schemas.microsoft.com/office/drawing/2014/main" id="{107E701A-6D80-47DE-A3C8-A17550537059}"/>
               </a:ext>
             </a:extLst>
           </p:cNvPr>
@@ -9466,7 +9466,7 @@
           <p:cNvPr id="7" name="">
             <a:extLst xmlns:a="http://schemas.openxmlformats.org/drawingml/2006/main">
               <a:ext uri="{FF2B5EF4-FFF2-40B4-BE49-F238E27FC236}">
-                <a16:creationId xmlns:a16="http://schemas.microsoft.com/office/drawing/2014/main" id="{A96ADB55-4218-4156-B600-0A30C7317F49}"/>
+                <a16:creationId xmlns:a16="http://schemas.microsoft.com/office/drawing/2014/main" id="{4A798470-100E-4940-B55A-586A5A10C701}"/>
               </a:ext>
             </a:extLst>
           </p:cNvPr>
@@ -9643,7 +9643,7 @@
     </p:spTree>
     <p:extLst>
       <p:ext uri="{BB962C8B-B14F-4D97-AF65-F5344CB8AC3E}">
-        <p14:creationId xmlns:p14="http://schemas.microsoft.com/office/powerpoint/2010/main" val="1764304328"/>
+        <p14:creationId xmlns:p14="http://schemas.microsoft.com/office/powerpoint/2010/main" val="544544023"/>
       </p:ext>
     </p:extLst>
   </p:cSld>
@@ -9674,7 +9674,7 @@
           <p:cNvPr id="9" name="">
             <a:extLst xmlns:a="http://schemas.openxmlformats.org/drawingml/2006/main">
               <a:ext uri="{FF2B5EF4-FFF2-40B4-BE49-F238E27FC236}">
-                <a16:creationId xmlns:a16="http://schemas.microsoft.com/office/drawing/2014/main" id="{B6CB65B3-4CA2-465C-B1AE-C71011499843}"/>
+                <a16:creationId xmlns:a16="http://schemas.microsoft.com/office/drawing/2014/main" id="{A2FD012E-B9E8-4CF9-8D05-58A8A888734B}"/>
               </a:ext>
             </a:extLst>
           </p:cNvPr>
@@ -9830,7 +9830,7 @@
           <p:cNvPr id="2" name="">
             <a:extLst xmlns:a="http://schemas.openxmlformats.org/drawingml/2006/main">
               <a:ext uri="{FF2B5EF4-FFF2-40B4-BE49-F238E27FC236}">
-                <a16:creationId xmlns:a16="http://schemas.microsoft.com/office/drawing/2014/main" id="{9B6A8B4C-9F3E-4460-BA06-E7D6A071C912}"/>
+                <a16:creationId xmlns:a16="http://schemas.microsoft.com/office/drawing/2014/main" id="{BA3EED25-DC51-4DB2-B486-2F477713471D}"/>
               </a:ext>
             </a:extLst>
           </p:cNvPr>
@@ -9986,7 +9986,7 @@
           <p:cNvPr id="3" name="">
             <a:extLst xmlns:a="http://schemas.openxmlformats.org/drawingml/2006/main">
               <a:ext uri="{FF2B5EF4-FFF2-40B4-BE49-F238E27FC236}">
-                <a16:creationId xmlns:a16="http://schemas.microsoft.com/office/drawing/2014/main" id="{023F6515-FA28-4606-9B1D-76712BDB6E5A}"/>
+                <a16:creationId xmlns:a16="http://schemas.microsoft.com/office/drawing/2014/main" id="{D7F8E497-020F-44A2-9D74-9BEE49ACC154}"/>
               </a:ext>
             </a:extLst>
           </p:cNvPr>
@@ -10142,7 +10142,7 @@
           <p:cNvPr id="4" name="">
             <a:extLst xmlns:a="http://schemas.openxmlformats.org/drawingml/2006/main">
               <a:ext uri="{FF2B5EF4-FFF2-40B4-BE49-F238E27FC236}">
-                <a16:creationId xmlns:a16="http://schemas.microsoft.com/office/drawing/2014/main" id="{E291F26E-FBA0-411C-AA08-9FE7DD8BBCED}"/>
+                <a16:creationId xmlns:a16="http://schemas.microsoft.com/office/drawing/2014/main" id="{844D340B-D18B-464B-AA5C-58F46E879747}"/>
               </a:ext>
             </a:extLst>
           </p:cNvPr>
@@ -10298,7 +10298,7 @@
           <p:cNvPr id="5" name="">
             <a:extLst xmlns:a="http://schemas.openxmlformats.org/drawingml/2006/main">
               <a:ext uri="{FF2B5EF4-FFF2-40B4-BE49-F238E27FC236}">
-                <a16:creationId xmlns:a16="http://schemas.microsoft.com/office/drawing/2014/main" id="{E660D5CB-3BF0-4832-98A7-65DDBB4F7A7F}"/>
+                <a16:creationId xmlns:a16="http://schemas.microsoft.com/office/drawing/2014/main" id="{80524306-BC06-4755-82D1-257F827108DA}"/>
               </a:ext>
             </a:extLst>
           </p:cNvPr>
@@ -10454,7 +10454,7 @@
           <p:cNvPr id="6" name="">
             <a:extLst xmlns:a="http://schemas.openxmlformats.org/drawingml/2006/main">
               <a:ext uri="{FF2B5EF4-FFF2-40B4-BE49-F238E27FC236}">
-                <a16:creationId xmlns:a16="http://schemas.microsoft.com/office/drawing/2014/main" id="{1B3E0DD4-35A1-4BF1-8308-48311D1958CC}"/>
+                <a16:creationId xmlns:a16="http://schemas.microsoft.com/office/drawing/2014/main" id="{99D26763-D367-4BF8-A174-EBA1888F8D54}"/>
               </a:ext>
             </a:extLst>
           </p:cNvPr>
@@ -10633,7 +10633,7 @@
           <p:cNvPr id="7" name="">
             <a:extLst xmlns:a="http://schemas.openxmlformats.org/drawingml/2006/main">
               <a:ext uri="{FF2B5EF4-FFF2-40B4-BE49-F238E27FC236}">
-                <a16:creationId xmlns:a16="http://schemas.microsoft.com/office/drawing/2014/main" id="{85DE068E-2829-4C20-B726-501D38596083}"/>
+                <a16:creationId xmlns:a16="http://schemas.microsoft.com/office/drawing/2014/main" id="{C0DB61E8-80CC-454E-A88E-2F914C706C8A}"/>
               </a:ext>
             </a:extLst>
           </p:cNvPr>
@@ -10789,7 +10789,7 @@
           <p:cNvPr id="8" name="">
             <a:extLst xmlns:a="http://schemas.openxmlformats.org/drawingml/2006/main">
               <a:ext uri="{FF2B5EF4-FFF2-40B4-BE49-F238E27FC236}">
-                <a16:creationId xmlns:a16="http://schemas.microsoft.com/office/drawing/2014/main" id="{38A0DDFC-D1B1-46F7-B6F7-BA0BE2CFD66F}"/>
+                <a16:creationId xmlns:a16="http://schemas.microsoft.com/office/drawing/2014/main" id="{0AF138E5-DEE7-4E26-9D4D-D0956F8B9736}"/>
               </a:ext>
             </a:extLst>
           </p:cNvPr>
@@ -10943,7 +10943,7 @@
     </p:spTree>
     <p:extLst>
       <p:ext uri="{BB962C8B-B14F-4D97-AF65-F5344CB8AC3E}">
-        <p14:creationId xmlns:p14="http://schemas.microsoft.com/office/powerpoint/2010/main" val="2123343537"/>
+        <p14:creationId xmlns:p14="http://schemas.microsoft.com/office/powerpoint/2010/main" val="383201112"/>
       </p:ext>
     </p:extLst>
   </p:cSld>
@@ -10974,7 +10974,7 @@
           <p:cNvPr id="9" name="">
             <a:extLst xmlns:a="http://schemas.openxmlformats.org/drawingml/2006/main">
               <a:ext uri="{FF2B5EF4-FFF2-40B4-BE49-F238E27FC236}">
-                <a16:creationId xmlns:a16="http://schemas.microsoft.com/office/drawing/2014/main" id="{6DA3F263-58BC-4E93-A5EF-B03AED03BA09}"/>
+                <a16:creationId xmlns:a16="http://schemas.microsoft.com/office/drawing/2014/main" id="{EAB6B0D7-6B9C-41D1-B8C8-1B60C82D6496}"/>
               </a:ext>
             </a:extLst>
           </p:cNvPr>
@@ -11130,7 +11130,7 @@
           <p:cNvPr id="2" name="">
             <a:extLst xmlns:a="http://schemas.openxmlformats.org/drawingml/2006/main">
               <a:ext uri="{FF2B5EF4-FFF2-40B4-BE49-F238E27FC236}">
-                <a16:creationId xmlns:a16="http://schemas.microsoft.com/office/drawing/2014/main" id="{3FEACB47-71E6-4F64-B52E-656C525D95C7}"/>
+                <a16:creationId xmlns:a16="http://schemas.microsoft.com/office/drawing/2014/main" id="{490E6C18-4DCB-4278-A2A5-F25070191DAB}"/>
               </a:ext>
             </a:extLst>
           </p:cNvPr>
@@ -11286,7 +11286,7 @@
           <p:cNvPr id="3" name="">
             <a:extLst xmlns:a="http://schemas.openxmlformats.org/drawingml/2006/main">
               <a:ext uri="{FF2B5EF4-FFF2-40B4-BE49-F238E27FC236}">
-                <a16:creationId xmlns:a16="http://schemas.microsoft.com/office/drawing/2014/main" id="{0382ADFD-672E-403B-86C1-6FA07DC1A740}"/>
+                <a16:creationId xmlns:a16="http://schemas.microsoft.com/office/drawing/2014/main" id="{3B1728DF-7CC7-4319-8250-E698D9C1340C}"/>
               </a:ext>
             </a:extLst>
           </p:cNvPr>
@@ -11442,7 +11442,7 @@
           <p:cNvPr id="4" name="">
             <a:extLst xmlns:a="http://schemas.openxmlformats.org/drawingml/2006/main">
               <a:ext uri="{FF2B5EF4-FFF2-40B4-BE49-F238E27FC236}">
-                <a16:creationId xmlns:a16="http://schemas.microsoft.com/office/drawing/2014/main" id="{C8282A43-CE61-4DC9-933D-B4C502930E1B}"/>
+                <a16:creationId xmlns:a16="http://schemas.microsoft.com/office/drawing/2014/main" id="{1FDB4CC0-8E6A-43AF-A5AB-24F2D5C59E66}"/>
               </a:ext>
             </a:extLst>
           </p:cNvPr>
@@ -11621,7 +11621,7 @@
           <p:cNvPr id="5" name="">
             <a:extLst xmlns:a="http://schemas.openxmlformats.org/drawingml/2006/main">
               <a:ext uri="{FF2B5EF4-FFF2-40B4-BE49-F238E27FC236}">
-                <a16:creationId xmlns:a16="http://schemas.microsoft.com/office/drawing/2014/main" id="{6A473AAB-27FB-4F1A-85E8-A14FC2D1517C}"/>
+                <a16:creationId xmlns:a16="http://schemas.microsoft.com/office/drawing/2014/main" id="{C7B3F6D4-5ACF-42ED-B487-E7117893040F}"/>
               </a:ext>
             </a:extLst>
           </p:cNvPr>
@@ -11777,7 +11777,7 @@
           <p:cNvPr id="6" name="">
             <a:extLst xmlns:a="http://schemas.openxmlformats.org/drawingml/2006/main">
               <a:ext uri="{FF2B5EF4-FFF2-40B4-BE49-F238E27FC236}">
-                <a16:creationId xmlns:a16="http://schemas.microsoft.com/office/drawing/2014/main" id="{E0EB1513-8980-49DC-A425-6015282F326F}"/>
+                <a16:creationId xmlns:a16="http://schemas.microsoft.com/office/drawing/2014/main" id="{DB980BD5-7E77-44E1-B487-E5D165EAAE2A}"/>
               </a:ext>
             </a:extLst>
           </p:cNvPr>
@@ -11956,7 +11956,7 @@
           <p:cNvPr id="7" name="">
             <a:extLst xmlns:a="http://schemas.openxmlformats.org/drawingml/2006/main">
               <a:ext uri="{FF2B5EF4-FFF2-40B4-BE49-F238E27FC236}">
-                <a16:creationId xmlns:a16="http://schemas.microsoft.com/office/drawing/2014/main" id="{E9897986-353D-45A1-9DFE-8CF319399A2B}"/>
+                <a16:creationId xmlns:a16="http://schemas.microsoft.com/office/drawing/2014/main" id="{5D2BEB0C-1FC0-4558-82B9-4752616A229B}"/>
               </a:ext>
             </a:extLst>
           </p:cNvPr>
@@ -12112,7 +12112,7 @@
           <p:cNvPr id="8" name="">
             <a:extLst xmlns:a="http://schemas.openxmlformats.org/drawingml/2006/main">
               <a:ext uri="{FF2B5EF4-FFF2-40B4-BE49-F238E27FC236}">
-                <a16:creationId xmlns:a16="http://schemas.microsoft.com/office/drawing/2014/main" id="{B225B3AD-8A3A-4357-95AE-2C69EB7D5FD5}"/>
+                <a16:creationId xmlns:a16="http://schemas.microsoft.com/office/drawing/2014/main" id="{89A7A01D-FA81-49EC-9E05-6288A134D280}"/>
               </a:ext>
             </a:extLst>
           </p:cNvPr>
@@ -12289,7 +12289,7 @@
     </p:spTree>
     <p:extLst>
       <p:ext uri="{BB962C8B-B14F-4D97-AF65-F5344CB8AC3E}">
-        <p14:creationId xmlns:p14="http://schemas.microsoft.com/office/powerpoint/2010/main" val="814717005"/>
+        <p14:creationId xmlns:p14="http://schemas.microsoft.com/office/powerpoint/2010/main" val="1875102641"/>
       </p:ext>
     </p:extLst>
   </p:cSld>

</xml_diff>